<commit_message>
Day3 g3_brain_ct: polish deck — fill sparse slides, fix card contrast, divider speaker notes
</commit_message>
<xml_diff>
--- a/solutions/g3_brain_ct/slides/g3_brain_ct.pptx
+++ b/solutions/g3_brain_ct/slides/g3_brain_ct.pptx
@@ -7,7 +7,7 @@
   <p:sldIdLst>
     <p:sldId id="256" r:id="rId7"/>
     <p:sldId id="257" r:id="rId8"/>
-    <p:sldId id="258" r:id="rId9"/>
+    <p:sldId id="258" r:id="rId10"/>
     <p:sldId id="259" r:id="rId11"/>
     <p:sldId id="260" r:id="rId12"/>
     <p:sldId id="261" r:id="rId13"/>
@@ -522,7 +522,7 @@
               <a:rPr b="1" sz="1300">
                 <a:latin typeface="Geist Mono"/>
               </a:rPr>
-              <a:t>Head-CT triage AI, in one picture</a:t>
+              <a:t>Background</a:t>
             </a:r>
           </a:p>
           <a:p>
@@ -530,13 +530,7 @@
               <a:rPr b="0" sz="1100">
                 <a:latin typeface="Geist"/>
               </a:rPr>
-              <a:t>Open concrete. The single most real, deployed use of AI on brain CT is triage: a network scans the whole
-stack and pushes probable bleeds to the top of the list so a radiologist reads the dangerous ones first,
-instead of in arrival order. In a busy ER that saves minutes that matter for a stroke. Ground it in real
-systems: Chilamkurthy 2018 (Lancet) trained on ~313,000 head CTs at AUC&gt;0.90; the RSNA 2019 challenge had
-60+ neuroradiologists label 25,000+ exams; Seyam 2022 is a deployed tool at ~93% accuracy. Then the catch:
-these tools are NOT equally good on every case. Transition: to even ask 'fair for whom', the data has to
-record who each scan came from.</a:t>
+              <a:t>This first section sets up WHY the project matters before any code: what head-CT AI actually does in a hospital, and why any fairness question needs data about who each scan came from. Keep it concrete -- the payoff is the missing-metadata twist later.</a:t>
             </a:r>
           </a:p>
         </p:txBody>
@@ -609,7 +603,7 @@
               <a:rPr b="1" sz="1300">
                 <a:latin typeface="Geist Mono"/>
               </a:rPr>
-              <a:t>Why that silence is disqualifying</a:t>
+              <a:t>Is it reading the brain, or cheating off the skull?</a:t>
             </a:r>
           </a:p>
           <a:p>
@@ -617,12 +611,11 @@
               <a:rPr b="0" sz="1100">
                 <a:latin typeface="Geist"/>
               </a:rPr>
-              <a:t>Land the thesis. Say it plainly: the model could be far worse for some group and we could not detect it. The
-literature agrees on both halves -- datasheets/reviews (Gebru 2021, Tripathi 2023) say document who is in the
-data; audits (Seyyed-Kalantari 2021, Yang 2024) show bias hides along demographic and scanner lines and is
-only visible where those labels exist. So for anything that would touch a patient, an un-runnable fairness
-audit is not a caveat you note at the end -- it is the finding. This is the sentence to end the talk on.
-Transition: the sources behind all of this.</a:t>
+              <a:t>Transparency audit. A model can be right for the wrong reason, so Grad-CAM overlays where the network actually
+looked to make each call. Honest read of our figure: some heat is on brain tissue, but some sits on the skull
+edge and the black border -- a shortcut. Tie it to Yang 2024: shortcut-learning is exactly why 'fair here'
+does not generalize. The teaching move is to SAY this out loud; naming a weakness is a stronger talk than
+hiding it. Transition: and it is brittle when the image gets messy.</a:t>
             </a:r>
           </a:p>
         </p:txBody>
@@ -695,6 +688,424 @@
               <a:rPr b="1" sz="1300">
                 <a:latin typeface="Geist Mono"/>
               </a:rPr>
+              <a:t>Does it survive a messier scan?</a:t>
+            </a:r>
+          </a:p>
+          <a:p>
+            <a:r>
+              <a:rPr b="0" sz="1100">
+                <a:latin typeface="Geist"/>
+              </a:rPr>
+              <a:t>Robustness / monitoring audit. Training data is clean; deployed scanners are messy (motion, low dose, other
+machines). We simulate that by adding increasing noise to the test images and watching accuracy -- it drops
+quickly, so this toy model is brittle. The real-world lesson: a shipped model meets drift, so it needs
+augmentation, more data, and live monitoring, not a one-time score. Transition: now the audit we cannot run
+at all -- the point of the whole project.</a:t>
+            </a:r>
+          </a:p>
+        </p:txBody>
+      </p:sp>
+      <p:sp>
+        <p:nvSpPr>
+          <p:cNvPr id="4" name="Slide Number Placeholder 3"/>
+          <p:cNvSpPr>
+            <a:spLocks noGrp="1"/>
+          </p:cNvSpPr>
+          <p:nvPr>
+            <p:ph type="sldNum" idx="5" sz="quarter"/>
+          </p:nvPr>
+        </p:nvSpPr>
+        <p:spPr/>
+      </p:sp>
+    </p:spTree>
+  </p:cSld>
+  <p:clrMapOvr>
+    <a:masterClrMapping/>
+  </p:clrMapOvr>
+</p:notes>
+</file>
+
+<file path=ppt/notesSlides/notesSlide12.xml><?xml version="1.0" encoding="utf-8"?>
+<p:notes xmlns:a="http://schemas.openxmlformats.org/drawingml/2006/main" xmlns:p="http://schemas.openxmlformats.org/presentationml/2006/main" xmlns:r="http://schemas.openxmlformats.org/officeDocument/2006/relationships">
+  <p:cSld>
+    <p:spTree>
+      <p:nvGrpSpPr>
+        <p:cNvPr id="1" name=""/>
+        <p:cNvGrpSpPr/>
+        <p:nvPr/>
+      </p:nvGrpSpPr>
+      <p:grpSpPr>
+        <a:xfrm>
+          <a:off x="0" y="0"/>
+          <a:ext cx="0" cy="0"/>
+          <a:chOff x="0" y="0"/>
+          <a:chExt cx="0" cy="0"/>
+        </a:xfrm>
+      </p:grpSpPr>
+      <p:sp>
+        <p:nvSpPr>
+          <p:cNvPr id="2" name="Slide Image Placeholder 1"/>
+          <p:cNvSpPr>
+            <a:spLocks noGrp="1"/>
+          </p:cNvSpPr>
+          <p:nvPr>
+            <p:ph type="sldImg" idx="2"/>
+          </p:nvPr>
+        </p:nvSpPr>
+        <p:spPr/>
+      </p:sp>
+      <p:sp>
+        <p:nvSpPr>
+          <p:cNvPr id="3" name="Notes Placeholder 2"/>
+          <p:cNvSpPr>
+            <a:spLocks noGrp="1"/>
+          </p:cNvSpPr>
+          <p:nvPr>
+            <p:ph type="body" idx="3" sz="quarter"/>
+          </p:nvPr>
+        </p:nvSpPr>
+        <p:spPr/>
+        <p:txBody>
+          <a:bodyPr/>
+          <a:lstStyle/>
+          <a:p>
+            <a:r>
+              <a:rPr b="1" sz="1300">
+                <a:latin typeface="Geist Mono"/>
+              </a:rPr>
+              <a:t>The gap that IS the finding</a:t>
+            </a:r>
+          </a:p>
+          <a:p>
+            <a:r>
+              <a:rPr b="0" sz="1100">
+                <a:latin typeface="Geist"/>
+              </a:rPr>
+              <a:t>This is the turn. Everything so far was a normal ML project; now we name the thing this dataset makes impossible -- a fairness audit -- and argue that the missing metadata is not a footnote but the headline finding.</a:t>
+            </a:r>
+          </a:p>
+        </p:txBody>
+      </p:sp>
+      <p:sp>
+        <p:nvSpPr>
+          <p:cNvPr id="4" name="Slide Number Placeholder 3"/>
+          <p:cNvSpPr>
+            <a:spLocks noGrp="1"/>
+          </p:cNvSpPr>
+          <p:nvPr>
+            <p:ph type="sldNum" idx="5" sz="quarter"/>
+          </p:nvPr>
+        </p:nvSpPr>
+        <p:spPr/>
+      </p:sp>
+    </p:spTree>
+  </p:cSld>
+  <p:clrMapOvr>
+    <a:masterClrMapping/>
+  </p:clrMapOvr>
+</p:notes>
+</file>
+
+<file path=ppt/notesSlides/notesSlide13.xml><?xml version="1.0" encoding="utf-8"?>
+<p:notes xmlns:a="http://schemas.openxmlformats.org/drawingml/2006/main" xmlns:p="http://schemas.openxmlformats.org/presentationml/2006/main" xmlns:r="http://schemas.openxmlformats.org/officeDocument/2006/relationships">
+  <p:cSld>
+    <p:spTree>
+      <p:nvGrpSpPr>
+        <p:cNvPr id="1" name=""/>
+        <p:cNvGrpSpPr/>
+        <p:nvPr/>
+      </p:nvGrpSpPr>
+      <p:grpSpPr>
+        <a:xfrm>
+          <a:off x="0" y="0"/>
+          <a:ext cx="0" cy="0"/>
+          <a:chOff x="0" y="0"/>
+          <a:chExt cx="0" cy="0"/>
+        </a:xfrm>
+      </p:grpSpPr>
+      <p:sp>
+        <p:nvSpPr>
+          <p:cNvPr id="2" name="Slide Image Placeholder 1"/>
+          <p:cNvSpPr>
+            <a:spLocks noGrp="1"/>
+          </p:cNvSpPr>
+          <p:nvPr>
+            <p:ph type="sldImg" idx="2"/>
+          </p:nvPr>
+        </p:nvSpPr>
+        <p:spPr/>
+      </p:sp>
+      <p:sp>
+        <p:nvSpPr>
+          <p:cNvPr id="3" name="Notes Placeholder 2"/>
+          <p:cNvSpPr>
+            <a:spLocks noGrp="1"/>
+          </p:cNvSpPr>
+          <p:nvPr>
+            <p:ph type="body" idx="3" sz="quarter"/>
+          </p:nvPr>
+        </p:nvSpPr>
+        <p:spPr/>
+        <p:txBody>
+          <a:bodyPr/>
+          <a:lstStyle/>
+          <a:p>
+            <a:r>
+              <a:rPr b="1" sz="1300">
+                <a:latin typeface="Geist Mono"/>
+              </a:rPr>
+              <a:t>The audit we literally cannot run</a:t>
+            </a:r>
+          </a:p>
+          <a:p>
+            <a:r>
+              <a:rPr b="0" sz="1100">
+                <a:latin typeface="Geist"/>
+              </a:rPr>
+              <a:t>The climax figure: a deliberately near-blank slide, a picture of metadata that does not exist. Draw the
+distinction crisply: we CAN audit by class (normal vs. stroke) because the label is recorded, but the audit
+that actually matters for fairness -- across age, sex, race, scanner -- cannot be run at all, because there is
+nothing to group by. Not hard; impossible. Let the emptiness of the figure do the work. Transition: why that
+silence is disqualifying, not a caveat.</a:t>
+            </a:r>
+          </a:p>
+        </p:txBody>
+      </p:sp>
+      <p:sp>
+        <p:nvSpPr>
+          <p:cNvPr id="4" name="Slide Number Placeholder 3"/>
+          <p:cNvSpPr>
+            <a:spLocks noGrp="1"/>
+          </p:cNvSpPr>
+          <p:nvPr>
+            <p:ph type="sldNum" idx="5" sz="quarter"/>
+          </p:nvPr>
+        </p:nvSpPr>
+        <p:spPr/>
+      </p:sp>
+    </p:spTree>
+  </p:cSld>
+  <p:clrMapOvr>
+    <a:masterClrMapping/>
+  </p:clrMapOvr>
+</p:notes>
+</file>
+
+<file path=ppt/notesSlides/notesSlide14.xml><?xml version="1.0" encoding="utf-8"?>
+<p:notes xmlns:a="http://schemas.openxmlformats.org/drawingml/2006/main" xmlns:p="http://schemas.openxmlformats.org/presentationml/2006/main" xmlns:r="http://schemas.openxmlformats.org/officeDocument/2006/relationships">
+  <p:cSld>
+    <p:spTree>
+      <p:nvGrpSpPr>
+        <p:cNvPr id="1" name=""/>
+        <p:cNvGrpSpPr/>
+        <p:nvPr/>
+      </p:nvGrpSpPr>
+      <p:grpSpPr>
+        <a:xfrm>
+          <a:off x="0" y="0"/>
+          <a:ext cx="0" cy="0"/>
+          <a:chOff x="0" y="0"/>
+          <a:chExt cx="0" cy="0"/>
+        </a:xfrm>
+      </p:grpSpPr>
+      <p:sp>
+        <p:nvSpPr>
+          <p:cNvPr id="2" name="Slide Image Placeholder 1"/>
+          <p:cNvSpPr>
+            <a:spLocks noGrp="1"/>
+          </p:cNvSpPr>
+          <p:nvPr>
+            <p:ph type="sldImg" idx="2"/>
+          </p:nvPr>
+        </p:nvSpPr>
+        <p:spPr/>
+      </p:sp>
+      <p:sp>
+        <p:nvSpPr>
+          <p:cNvPr id="3" name="Notes Placeholder 2"/>
+          <p:cNvSpPr>
+            <a:spLocks noGrp="1"/>
+          </p:cNvSpPr>
+          <p:nvPr>
+            <p:ph type="body" idx="3" sz="quarter"/>
+          </p:nvPr>
+        </p:nvSpPr>
+        <p:spPr/>
+        <p:txBody>
+          <a:bodyPr/>
+          <a:lstStyle/>
+          <a:p>
+            <a:r>
+              <a:rPr b="1" sz="1300">
+                <a:latin typeface="Geist Mono"/>
+              </a:rPr>
+              <a:t>Why that silence is disqualifying</a:t>
+            </a:r>
+          </a:p>
+          <a:p>
+            <a:r>
+              <a:rPr b="0" sz="1100">
+                <a:latin typeface="Geist"/>
+              </a:rPr>
+              <a:t>Land the thesis. Say it plainly: the model could be far worse for some group and we could not detect it. The
+literature agrees on both halves -- datasheets/reviews (Gebru 2021, Tripathi 2023) say document who is in the
+data; audits (Seyyed-Kalantari 2021, Yang 2024) show bias hides along demographic and scanner lines and is
+only visible where those labels exist. So for anything that would touch a patient, an un-runnable fairness
+audit is not a caveat you note at the end -- it is the finding. This is the sentence to end the talk on.
+Transition: the sources behind all of this.</a:t>
+            </a:r>
+          </a:p>
+        </p:txBody>
+      </p:sp>
+      <p:sp>
+        <p:nvSpPr>
+          <p:cNvPr id="4" name="Slide Number Placeholder 3"/>
+          <p:cNvSpPr>
+            <a:spLocks noGrp="1"/>
+          </p:cNvSpPr>
+          <p:nvPr>
+            <p:ph type="sldNum" idx="5" sz="quarter"/>
+          </p:nvPr>
+        </p:nvSpPr>
+        <p:spPr/>
+      </p:sp>
+    </p:spTree>
+  </p:cSld>
+  <p:clrMapOvr>
+    <a:masterClrMapping/>
+  </p:clrMapOvr>
+</p:notes>
+</file>
+
+<file path=ppt/notesSlides/notesSlide15.xml><?xml version="1.0" encoding="utf-8"?>
+<p:notes xmlns:a="http://schemas.openxmlformats.org/drawingml/2006/main" xmlns:p="http://schemas.openxmlformats.org/presentationml/2006/main" xmlns:r="http://schemas.openxmlformats.org/officeDocument/2006/relationships">
+  <p:cSld>
+    <p:spTree>
+      <p:nvGrpSpPr>
+        <p:cNvPr id="1" name=""/>
+        <p:cNvGrpSpPr/>
+        <p:nvPr/>
+      </p:nvGrpSpPr>
+      <p:grpSpPr>
+        <a:xfrm>
+          <a:off x="0" y="0"/>
+          <a:ext cx="0" cy="0"/>
+          <a:chOff x="0" y="0"/>
+          <a:chExt cx="0" cy="0"/>
+        </a:xfrm>
+      </p:grpSpPr>
+      <p:sp>
+        <p:nvSpPr>
+          <p:cNvPr id="2" name="Slide Image Placeholder 1"/>
+          <p:cNvSpPr>
+            <a:spLocks noGrp="1"/>
+          </p:cNvSpPr>
+          <p:nvPr>
+            <p:ph type="sldImg" idx="2"/>
+          </p:nvPr>
+        </p:nvSpPr>
+        <p:spPr/>
+      </p:sp>
+      <p:sp>
+        <p:nvSpPr>
+          <p:cNvPr id="3" name="Notes Placeholder 2"/>
+          <p:cNvSpPr>
+            <a:spLocks noGrp="1"/>
+          </p:cNvSpPr>
+          <p:nvPr>
+            <p:ph type="body" idx="3" sz="quarter"/>
+          </p:nvPr>
+        </p:nvSpPr>
+        <p:spPr/>
+        <p:txBody>
+          <a:bodyPr/>
+          <a:lstStyle/>
+          <a:p>
+            <a:r>
+              <a:rPr b="1" sz="1300">
+                <a:latin typeface="Geist Mono"/>
+              </a:rPr>
+              <a:t>References</a:t>
+            </a:r>
+          </a:p>
+          <a:p>
+            <a:r>
+              <a:rPr b="0" sz="1100">
+                <a:latin typeface="Geist"/>
+              </a:rPr>
+              <a:t>The sources behind every claim, grouped by the role each plays: the real triage systems that motivate the task, the dataset-documentation argument, and the fairness audits that only work when metadata exists.</a:t>
+            </a:r>
+          </a:p>
+        </p:txBody>
+      </p:sp>
+      <p:sp>
+        <p:nvSpPr>
+          <p:cNvPr id="4" name="Slide Number Placeholder 3"/>
+          <p:cNvSpPr>
+            <a:spLocks noGrp="1"/>
+          </p:cNvSpPr>
+          <p:nvPr>
+            <p:ph type="sldNum" idx="5" sz="quarter"/>
+          </p:nvPr>
+        </p:nvSpPr>
+        <p:spPr/>
+      </p:sp>
+    </p:spTree>
+  </p:cSld>
+  <p:clrMapOvr>
+    <a:masterClrMapping/>
+  </p:clrMapOvr>
+</p:notes>
+</file>
+
+<file path=ppt/notesSlides/notesSlide16.xml><?xml version="1.0" encoding="utf-8"?>
+<p:notes xmlns:a="http://schemas.openxmlformats.org/drawingml/2006/main" xmlns:p="http://schemas.openxmlformats.org/presentationml/2006/main" xmlns:r="http://schemas.openxmlformats.org/officeDocument/2006/relationships">
+  <p:cSld>
+    <p:spTree>
+      <p:nvGrpSpPr>
+        <p:cNvPr id="1" name=""/>
+        <p:cNvGrpSpPr/>
+        <p:nvPr/>
+      </p:nvGrpSpPr>
+      <p:grpSpPr>
+        <a:xfrm>
+          <a:off x="0" y="0"/>
+          <a:ext cx="0" cy="0"/>
+          <a:chOff x="0" y="0"/>
+          <a:chExt cx="0" cy="0"/>
+        </a:xfrm>
+      </p:grpSpPr>
+      <p:sp>
+        <p:nvSpPr>
+          <p:cNvPr id="2" name="Slide Image Placeholder 1"/>
+          <p:cNvSpPr>
+            <a:spLocks noGrp="1"/>
+          </p:cNvSpPr>
+          <p:nvPr>
+            <p:ph type="sldImg" idx="2"/>
+          </p:nvPr>
+        </p:nvSpPr>
+        <p:spPr/>
+      </p:sp>
+      <p:sp>
+        <p:nvSpPr>
+          <p:cNvPr id="3" name="Notes Placeholder 2"/>
+          <p:cNvSpPr>
+            <a:spLocks noGrp="1"/>
+          </p:cNvSpPr>
+          <p:nvPr>
+            <p:ph type="body" idx="3" sz="quarter"/>
+          </p:nvPr>
+        </p:nvSpPr>
+        <p:spPr/>
+        <p:txBody>
+          <a:bodyPr/>
+          <a:lstStyle/>
+          <a:p>
+            <a:r>
+              <a:rPr b="1" sz="1300">
+                <a:latin typeface="Geist Mono"/>
+              </a:rPr>
               <a:t>References</a:t>
             </a:r>
           </a:p>
@@ -779,7 +1190,7 @@
               <a:rPr b="1" sz="1300">
                 <a:latin typeface="Geist Mono"/>
               </a:rPr>
-              <a:t>A dataset should tell you who is in it</a:t>
+              <a:t>Head-CT triage AI, in one picture</a:t>
             </a:r>
           </a:p>
           <a:p>
@@ -787,12 +1198,13 @@
               <a:rPr b="0" sz="1100">
                 <a:latin typeface="Geist"/>
               </a:rPr>
-              <a:t>This is the pivot from 'cool tool' to 'the real lesson'. A fairness check is a comparison ACROSS groups, so
-it needs the grouping columns to exist. The Datasheets for Datasets idea (Gebru 2021) proposes every dataset
-ship a standard sheet answering who is in it, how it was labeled, and its limits. Reviews (Tripathi 2023)
-find radiology datasets routinely leave those blank. Left figure: the six things a datasheet asks vs. the two
-our brain-CT set actually has -- four demographic rows are empty. Transition: and empty rows mean unfillable
-audit bars.</a:t>
+              <a:t>Open concrete. The single most real, deployed use of AI on brain CT is triage: a network scans the whole
+stack and pushes probable bleeds to the top of the list so a radiologist reads the dangerous ones first,
+instead of in arrival order. In a busy ER that saves minutes that matter for a stroke. Ground it in real
+systems: Chilamkurthy 2018 (Lancet) trained on ~313,000 head CTs at AUC&gt;0.90; the RSNA 2019 challenge had
+60+ neuroradiologists label 25,000+ exams; Seyam 2022 is a deployed tool at ~93% accuracy. Then the catch:
+these tools are NOT equally good on every case. Transition: to even ask 'fair for whom', the data has to
+record who each scan came from.</a:t>
             </a:r>
           </a:p>
         </p:txBody>
@@ -865,7 +1277,7 @@
               <a:rPr b="1" sz="1300">
                 <a:latin typeface="Geist Mono"/>
               </a:rPr>
-              <a:t>You can’t audit a bias you can’t see</a:t>
+              <a:t>A dataset should tell you who is in it</a:t>
             </a:r>
           </a:p>
           <a:p>
@@ -873,12 +1285,12 @@
               <a:rPr b="0" sz="1100">
                 <a:latin typeface="Geist"/>
               </a:rPr>
-              <a:t>Make the abstract concrete with real findings. Seyyed-Kalantari 2021 (Nature Medicine): chest-X-ray AI gave
-more false 'no finding' calls for female, Black, and low-income patients -- underdiagnosis that only showed
-up BECAUSE those datasets recorded the groups. Yang 2024 (Nature Medicine): imaging AI often rides demographic
-shortcuts, so fairness measured on one hospital does not transfer. The figure equates missing metadata with a
-blind spot: one measurable bar, the rest drawn as empty dashed outlines labeled 'no data -- cannot measure'.
-Transition: now our own build, on exactly such a dataset.</a:t>
+              <a:t>This is the pivot from 'cool tool' to 'the real lesson'. A fairness check is a comparison ACROSS groups, so
+it needs the grouping columns to exist. The Datasheets for Datasets idea (Gebru 2021) proposes every dataset
+ship a standard sheet answering who is in it, how it was labeled, and its limits. Reviews (Tripathi 2023)
+find radiology datasets routinely leave those blank. Left figure: the six things a datasheet asks vs. the two
+our brain-CT set actually has -- four demographic rows are empty. Transition: and empty rows mean unfillable
+audit bars.</a:t>
             </a:r>
           </a:p>
         </p:txBody>
@@ -951,7 +1363,7 @@
               <a:rPr b="1" sz="1300">
                 <a:latin typeface="Geist Mono"/>
               </a:rPr>
-              <a:t>The task and the data</a:t>
+              <a:t>You can’t audit a bias you can’t see</a:t>
             </a:r>
           </a:p>
           <a:p>
@@ -959,11 +1371,12 @@
               <a:rPr b="0" sz="1100">
                 <a:latin typeface="Geist"/>
               </a:rPr>
-              <a:t>State the problem and, deliberately, the absence. The task is a clean binary: normal vs. stroke on a 64x64
-brain slice. What the model is GIVEN is only the image and the label. What is MISSING is every field a
-fairness audit needs -- age, sex, race, scanner, site, time-since-injury. The pink 'Missing' card is the one
-to linger on; it is the whole story of this project set up in advance. Transition: how we actually build the
-detector.</a:t>
+              <a:t>Make the abstract concrete with real findings. Seyyed-Kalantari 2021 (Nature Medicine): chest-X-ray AI gave
+more false 'no finding' calls for female, Black, and low-income patients -- underdiagnosis that only showed
+up BECAUSE those datasets recorded the groups. Yang 2024 (Nature Medicine): imaging AI often rides demographic
+shortcuts, so fairness measured on one hospital does not transfer. The figure equates missing metadata with a
+blind spot: one measurable bar, the rest drawn as empty dashed outlines labeled 'no data -- cannot measure'.
+Transition: now our own build, on exactly such a dataset.</a:t>
             </a:r>
           </a:p>
         </p:txBody>
@@ -1036,7 +1449,7 @@
               <a:rPr b="1" sz="1300">
                 <a:latin typeface="Geist Mono"/>
               </a:rPr>
-              <a:t>The idea: reuse a pretrained network</a:t>
+              <a:t>Methods</a:t>
             </a:r>
           </a:p>
           <a:p>
@@ -1044,11 +1457,7 @@
               <a:rPr b="0" sz="1100">
                 <a:latin typeface="Geist"/>
               </a:rPr>
-              <a:t>One transferable idea, echoed from Day 1: transfer learning. On a few hundred scans you cannot teach a network
-to see from scratch, so you borrow a ResNet18 already trained on a million ImageNet photos, freeze the body
-that learned generic edges and textures, and train only a small new 2-class head. The chip flow makes the
-three moves concrete: pretrained backbone, freeze, new head. Emphasize the habit: when data is small, start
-from something pretrained. Transition: does it work? Grade it honestly.</a:t>
+              <a:t>Now we pin down exactly what we built: the classification task, the bare dataset we were handed, and the one reusable idea -- transfer learning -- that makes it work on so few scans. A short setup section before the results.</a:t>
             </a:r>
           </a:p>
         </p:txBody>
@@ -1121,7 +1530,7 @@
               <a:rPr b="1" sz="1300">
                 <a:latin typeface="Geist Mono"/>
               </a:rPr>
-              <a:t>It catches most strokes — but cries wolf</a:t>
+              <a:t>The task and the data</a:t>
             </a:r>
           </a:p>
           <a:p>
@@ -1129,12 +1538,11 @@
               <a:rPr b="0" sz="1100">
                 <a:latin typeface="Geist"/>
               </a:rPr>
-              <a:t>The honest-evaluation slide, and the metric lesson. On the held-out test set overall accuracy is ~0.71, but
-that is the wrong headline for screening. Break it into the two error types: sensitivity ~0.84 means it
-catches most real strokes (the error we most want to avoid), while specificity ~0.60 means it false-alarms on
-many normal scans. The confusion matrix shows the same split as a picture. Point: for a triage safety-net you
-would tune toward sensitivity on purpose -- crying wolf beats missing a bleed -- and a single accuracy number
-would have hidden it. Transition: but is it right for the right reason?</a:t>
+              <a:t>State the problem and, deliberately, the absence. The task is a clean binary: normal vs. stroke on a 64x64
+brain slice. What the model is GIVEN is only the image and the label. What is MISSING is every field a
+fairness audit needs -- age, sex, race, scanner, site, time-since-injury. The pink 'Missing' card is the one
+to linger on; it is the whole story of this project set up in advance. Transition: how we actually build the
+detector.</a:t>
             </a:r>
           </a:p>
         </p:txBody>
@@ -1207,7 +1615,7 @@
               <a:rPr b="1" sz="1300">
                 <a:latin typeface="Geist Mono"/>
               </a:rPr>
-              <a:t>Is it reading the brain, or cheating off the skull?</a:t>
+              <a:t>The idea: reuse a pretrained network</a:t>
             </a:r>
           </a:p>
           <a:p>
@@ -1215,11 +1623,11 @@
               <a:rPr b="0" sz="1100">
                 <a:latin typeface="Geist"/>
               </a:rPr>
-              <a:t>Transparency audit. A model can be right for the wrong reason, so Grad-CAM overlays where the network actually
-looked to make each call. Honest read of our figure: some heat is on brain tissue, but some sits on the skull
-edge and the black border -- a shortcut. Tie it to Yang 2024: shortcut-learning is exactly why 'fair here'
-does not generalize. The teaching move is to SAY this out loud; naming a weakness is a stronger talk than
-hiding it. Transition: and it is brittle when the image gets messy.</a:t>
+              <a:t>One transferable idea, echoed from Day 1: transfer learning. On a few hundred scans you cannot teach a network
+to see from scratch, so you borrow a ResNet18 already trained on a million ImageNet photos, freeze the body
+that learned generic edges and textures, and train only a small new 2-class head. The chip flow makes the
+three moves concrete: pretrained backbone, freeze, new head. Emphasize the habit: when data is small, start
+from something pretrained. Transition: does it work? Grade it honestly.</a:t>
             </a:r>
           </a:p>
         </p:txBody>
@@ -1292,7 +1700,7 @@
               <a:rPr b="1" sz="1300">
                 <a:latin typeface="Geist Mono"/>
               </a:rPr>
-              <a:t>Does it survive a messier scan?</a:t>
+              <a:t>Results</a:t>
             </a:r>
           </a:p>
           <a:p>
@@ -1300,11 +1708,7 @@
               <a:rPr b="0" sz="1100">
                 <a:latin typeface="Geist"/>
               </a:rPr>
-              <a:t>Robustness / monitoring audit. Training data is clean; deployed scanners are messy (motion, low dose, other
-machines). We simulate that by adding increasing noise to the test images and watching accuracy -- it drops
-quickly, so this toy model is brittle. The real-world lesson: a shipped model meets drift, so it needs
-augmentation, more data, and live monitoring, not a one-time score. Transition: now the audit we cannot run
-at all -- the point of the whole project.</a:t>
+              <a:t>Three honest checks on the model we trained: does it catch strokes, is it looking at the right pixels, and does it survive a noisier scan. The theme is honest evaluation -- we report the weaknesses, not just the headline accuracy.</a:t>
             </a:r>
           </a:p>
         </p:txBody>
@@ -1377,7 +1781,7 @@
               <a:rPr b="1" sz="1300">
                 <a:latin typeface="Geist Mono"/>
               </a:rPr>
-              <a:t>The audit we literally cannot run</a:t>
+              <a:t>It catches most strokes — but cries wolf</a:t>
             </a:r>
           </a:p>
           <a:p>
@@ -1385,11 +1789,12 @@
               <a:rPr b="0" sz="1100">
                 <a:latin typeface="Geist"/>
               </a:rPr>
-              <a:t>The climax figure: a deliberately near-blank slide, a picture of metadata that does not exist. Draw the
-distinction crisply: we CAN audit by class (normal vs. stroke) because the label is recorded, but the audit
-that actually matters for fairness -- across age, sex, race, scanner -- cannot be run at all, because there is
-nothing to group by. Not hard; impossible. Let the emptiness of the figure do the work. Transition: why that
-silence is disqualifying, not a caveat.</a:t>
+              <a:t>The honest-evaluation slide, and the metric lesson. On the held-out test set overall accuracy is ~0.71, but
+that is the wrong headline for screening. Break it into the two error types: sensitivity ~0.84 means it
+catches most real strokes (the error we most want to avoid), while specificity ~0.60 means it false-alarms on
+many normal scans. The confusion matrix shows the same split as a picture. Point: for a triage safety-net you
+would tune toward sensitivity on purpose -- crying wolf beats missing a bleed -- and a single accuracy number
+would have hidden it. Transition: but is it right for the right reason?</a:t>
             </a:r>
           </a:p>
         </p:txBody>
@@ -5175,9 +5580,9 @@
           <a:p>
             <a:pPr algn="l"/>
             <a:r>
-              <a:rPr sz="1300" b="0" i="0">
+              <a:rPr sz="1400" b="0" i="0">
                 <a:solidFill>
-                  <a:srgbClr val="555560"/>
+                  <a:srgbClr val="14141C"/>
                 </a:solidFill>
                 <a:latin typeface="Geist"/>
               </a:rPr>
@@ -5445,7 +5850,7 @@
             <a:avLst/>
           </a:prstGeom>
           <a:solidFill>
-            <a:srgbClr val="FAFAFC"/>
+            <a:srgbClr val="FFFFFF"/>
           </a:solidFill>
           <a:ln>
             <a:noFill/>
@@ -5847,7 +6252,7 @@
             <a:avLst/>
           </a:prstGeom>
           <a:solidFill>
-            <a:srgbClr val="FAFAFC"/>
+            <a:srgbClr val="FFFFFF"/>
           </a:solidFill>
           <a:ln>
             <a:noFill/>
@@ -6696,7 +7101,7 @@
             <a:avLst/>
           </a:prstGeom>
           <a:solidFill>
-            <a:srgbClr val="FAFAFC"/>
+            <a:srgbClr val="FFFFFF"/>
           </a:solidFill>
           <a:ln>
             <a:noFill/>
@@ -7067,7 +7472,7 @@
         </p:nvSpPr>
         <p:spPr>
           <a:xfrm>
-            <a:off x="457200" y="2406700"/>
+            <a:off x="457200" y="2093976"/>
             <a:ext cx="11247120" cy="1005840"/>
           </a:xfrm>
           <a:prstGeom prst="rect">
@@ -7096,14 +7501,58 @@
       </p:sp>
       <p:sp>
         <p:nvSpPr>
-          <p:cNvPr id="8" name="TextBox 7"/>
+          <p:cNvPr id="8" name="Rectangle 7"/>
+          <p:cNvSpPr/>
+          <p:nvPr/>
+        </p:nvSpPr>
+        <p:spPr>
+          <a:xfrm>
+            <a:off x="5180990" y="3240633"/>
+            <a:ext cx="1799539" cy="32004"/>
+          </a:xfrm>
+          <a:prstGeom prst="rect">
+            <a:avLst/>
+          </a:prstGeom>
+          <a:solidFill>
+            <a:srgbClr val="8A2BE2"/>
+          </a:solidFill>
+          <a:ln>
+            <a:noFill/>
+          </a:ln>
+          <a:effectLst/>
+        </p:spPr>
+        <p:style>
+          <a:lnRef idx="1">
+            <a:schemeClr val="accent1"/>
+          </a:lnRef>
+          <a:fillRef idx="3">
+            <a:schemeClr val="accent1"/>
+          </a:fillRef>
+          <a:effectRef idx="2">
+            <a:schemeClr val="accent1"/>
+          </a:effectRef>
+          <a:fontRef idx="minor">
+            <a:schemeClr val="lt1"/>
+          </a:fontRef>
+        </p:style>
+        <p:txBody>
+          <a:bodyPr rtlCol="0" anchor="ctr"/>
+          <a:lstStyle/>
+          <a:p>
+            <a:pPr algn="ctr"/>
+          </a:p>
+        </p:txBody>
+      </p:sp>
+      <p:sp>
+        <p:nvSpPr>
+          <p:cNvPr id="9" name="TextBox 8"/>
           <p:cNvSpPr txBox="1"/>
           <p:nvPr/>
         </p:nvSpPr>
         <p:spPr>
           <a:xfrm>
             <a:off x="1371600" y="3761841"/>
-            <a:ext cx="9418320" cy="1554480"/>
+            <a:ext cx="9418320" cy="2084831"/>
           </a:xfrm>
           <a:prstGeom prst="rect">
             <a:avLst/>
@@ -7804,14 +8253,14 @@
         </p:nvSpPr>
         <p:spPr>
           <a:xfrm>
-            <a:off x="457200" y="1325880"/>
-            <a:ext cx="3535680" cy="4434840"/>
+            <a:off x="457200" y="1252728"/>
+            <a:ext cx="3535680" cy="2710281"/>
           </a:xfrm>
           <a:prstGeom prst="rect">
             <a:avLst/>
           </a:prstGeom>
           <a:solidFill>
-            <a:srgbClr val="FAFAFC"/>
+            <a:srgbClr val="FFFFFF"/>
           </a:solidFill>
           <a:ln>
             <a:noFill/>
@@ -7848,7 +8297,7 @@
         </p:nvSpPr>
         <p:spPr>
           <a:xfrm>
-            <a:off x="457200" y="1325880"/>
+            <a:off x="457200" y="1252728"/>
             <a:ext cx="3535680" cy="54864"/>
           </a:xfrm>
           <a:prstGeom prst="rect">
@@ -7892,7 +8341,7 @@
         </p:nvSpPr>
         <p:spPr>
           <a:xfrm>
-            <a:off x="621792" y="1417320"/>
+            <a:off x="621792" y="1344168"/>
             <a:ext cx="3206496" cy="384048"/>
           </a:xfrm>
           <a:prstGeom prst="rect">
@@ -7927,8 +8376,8 @@
         </p:nvSpPr>
         <p:spPr>
           <a:xfrm>
-            <a:off x="621792" y="1965960"/>
-            <a:ext cx="3206496" cy="3703320"/>
+            <a:off x="621792" y="1892808"/>
+            <a:ext cx="3206496" cy="1978761"/>
           </a:xfrm>
           <a:prstGeom prst="rect">
             <a:avLst/>
@@ -7962,14 +8411,14 @@
         </p:nvSpPr>
         <p:spPr>
           <a:xfrm>
-            <a:off x="4312920" y="1325880"/>
-            <a:ext cx="3535680" cy="4434840"/>
+            <a:off x="4312920" y="1252728"/>
+            <a:ext cx="3535680" cy="2710281"/>
           </a:xfrm>
           <a:prstGeom prst="rect">
             <a:avLst/>
           </a:prstGeom>
           <a:solidFill>
-            <a:srgbClr val="FAFAFC"/>
+            <a:srgbClr val="FFFFFF"/>
           </a:solidFill>
           <a:ln>
             <a:noFill/>
@@ -8006,7 +8455,7 @@
         </p:nvSpPr>
         <p:spPr>
           <a:xfrm>
-            <a:off x="4312920" y="1325880"/>
+            <a:off x="4312920" y="1252728"/>
             <a:ext cx="3535680" cy="54864"/>
           </a:xfrm>
           <a:prstGeom prst="rect">
@@ -8050,7 +8499,7 @@
         </p:nvSpPr>
         <p:spPr>
           <a:xfrm>
-            <a:off x="4477512" y="1417320"/>
+            <a:off x="4477512" y="1344168"/>
             <a:ext cx="3206496" cy="384048"/>
           </a:xfrm>
           <a:prstGeom prst="rect">
@@ -8085,8 +8534,8 @@
         </p:nvSpPr>
         <p:spPr>
           <a:xfrm>
-            <a:off x="4477512" y="1965960"/>
-            <a:ext cx="3206496" cy="3703320"/>
+            <a:off x="4477512" y="1892808"/>
+            <a:ext cx="3206496" cy="1978761"/>
           </a:xfrm>
           <a:prstGeom prst="rect">
             <a:avLst/>
@@ -8120,14 +8569,14 @@
         </p:nvSpPr>
         <p:spPr>
           <a:xfrm>
-            <a:off x="8168640" y="1325880"/>
-            <a:ext cx="3535680" cy="4434840"/>
+            <a:off x="8168640" y="1252728"/>
+            <a:ext cx="3535680" cy="2710281"/>
           </a:xfrm>
           <a:prstGeom prst="rect">
             <a:avLst/>
           </a:prstGeom>
           <a:solidFill>
-            <a:srgbClr val="FAFAFC"/>
+            <a:srgbClr val="FFFFFF"/>
           </a:solidFill>
           <a:ln>
             <a:noFill/>
@@ -8164,7 +8613,7 @@
         </p:nvSpPr>
         <p:spPr>
           <a:xfrm>
-            <a:off x="8168640" y="1325880"/>
+            <a:off x="8168640" y="1252728"/>
             <a:ext cx="3535680" cy="54864"/>
           </a:xfrm>
           <a:prstGeom prst="rect">
@@ -8208,7 +8657,7 @@
         </p:nvSpPr>
         <p:spPr>
           <a:xfrm>
-            <a:off x="8333232" y="1417320"/>
+            <a:off x="8333232" y="1344168"/>
             <a:ext cx="3206496" cy="384048"/>
           </a:xfrm>
           <a:prstGeom prst="rect">
@@ -8243,8 +8692,8 @@
         </p:nvSpPr>
         <p:spPr>
           <a:xfrm>
-            <a:off x="8333232" y="1965960"/>
-            <a:ext cx="3206496" cy="3703320"/>
+            <a:off x="8333232" y="1892808"/>
+            <a:ext cx="3206496" cy="1978761"/>
           </a:xfrm>
           <a:prstGeom prst="rect">
             <a:avLst/>
@@ -8266,6 +8715,85 @@
                 <a:latin typeface="Geist"/>
               </a:rPr>
               <a:t>Seyyed-Kalantari 2021 (Nature Medicine); Yang 2024 (Nature Medicine).</a:t>
+            </a:r>
+          </a:p>
+        </p:txBody>
+      </p:sp>
+      <p:sp>
+        <p:nvSpPr>
+          <p:cNvPr id="19" name="Rectangle 18"/>
+          <p:cNvSpPr/>
+          <p:nvPr/>
+        </p:nvSpPr>
+        <p:spPr>
+          <a:xfrm>
+            <a:off x="457200" y="4432096"/>
+            <a:ext cx="64008" cy="833932"/>
+          </a:xfrm>
+          <a:prstGeom prst="rect">
+            <a:avLst/>
+          </a:prstGeom>
+          <a:solidFill>
+            <a:srgbClr val="40E0D0"/>
+          </a:solidFill>
+          <a:ln>
+            <a:noFill/>
+          </a:ln>
+          <a:effectLst/>
+        </p:spPr>
+        <p:style>
+          <a:lnRef idx="1">
+            <a:schemeClr val="accent1"/>
+          </a:lnRef>
+          <a:fillRef idx="3">
+            <a:schemeClr val="accent1"/>
+          </a:fillRef>
+          <a:effectRef idx="2">
+            <a:schemeClr val="accent1"/>
+          </a:effectRef>
+          <a:fontRef idx="minor">
+            <a:schemeClr val="lt1"/>
+          </a:fontRef>
+        </p:style>
+        <p:txBody>
+          <a:bodyPr rtlCol="0" anchor="ctr"/>
+          <a:lstStyle/>
+          <a:p>
+            <a:pPr algn="ctr"/>
+          </a:p>
+        </p:txBody>
+      </p:sp>
+      <p:sp>
+        <p:nvSpPr>
+          <p:cNvPr id="20" name="TextBox 19"/>
+          <p:cNvSpPr txBox="1"/>
+          <p:nvPr/>
+        </p:nvSpPr>
+        <p:spPr>
+          <a:xfrm>
+            <a:off x="731520" y="4432096"/>
+            <a:ext cx="10972800" cy="833932"/>
+          </a:xfrm>
+          <a:prstGeom prst="rect">
+            <a:avLst/>
+          </a:prstGeom>
+          <a:noFill/>
+        </p:spPr>
+        <p:txBody>
+          <a:bodyPr wrap="square" anchor="ctr" lIns="0" rIns="0" tIns="0" bIns="0">
+            <a:spAutoFit/>
+          </a:bodyPr>
+          <a:lstStyle/>
+          <a:p>
+            <a:pPr algn="l"/>
+            <a:r>
+              <a:rPr sz="1700" b="0" i="0">
+                <a:solidFill>
+                  <a:srgbClr val="14141C"/>
+                </a:solidFill>
+                <a:latin typeface="Geist"/>
+              </a:rPr>
+              <a:t>Every claim in this deck traces back to one of these sources.</a:t>
             </a:r>
           </a:p>
         </p:txBody>
@@ -9357,7 +9885,7 @@
             <a:avLst/>
           </a:prstGeom>
           <a:solidFill>
-            <a:srgbClr val="FAFAFC"/>
+            <a:srgbClr val="FFFFFF"/>
           </a:solidFill>
           <a:ln>
             <a:noFill/>
@@ -9759,7 +10287,7 @@
             <a:avLst/>
           </a:prstGeom>
           <a:solidFill>
-            <a:srgbClr val="FAFAFC"/>
+            <a:srgbClr val="FFFFFF"/>
           </a:solidFill>
           <a:ln>
             <a:noFill/>
@@ -10161,7 +10689,7 @@
             <a:avLst/>
           </a:prstGeom>
           <a:solidFill>
-            <a:srgbClr val="FAFAFC"/>
+            <a:srgbClr val="FFFFFF"/>
           </a:solidFill>
           <a:ln>
             <a:noFill/>
@@ -10979,14 +11507,14 @@
         </p:nvSpPr>
         <p:spPr>
           <a:xfrm>
-            <a:off x="457200" y="1325880"/>
-            <a:ext cx="3535680" cy="4434840"/>
+            <a:off x="457200" y="1161288"/>
+            <a:ext cx="3535680" cy="2606039"/>
           </a:xfrm>
           <a:prstGeom prst="rect">
             <a:avLst/>
           </a:prstGeom>
           <a:solidFill>
-            <a:srgbClr val="FAFAFC"/>
+            <a:srgbClr val="FFFFFF"/>
           </a:solidFill>
           <a:ln>
             <a:noFill/>
@@ -11023,7 +11551,7 @@
         </p:nvSpPr>
         <p:spPr>
           <a:xfrm>
-            <a:off x="457200" y="1325880"/>
+            <a:off x="457200" y="1161288"/>
             <a:ext cx="3535680" cy="54864"/>
           </a:xfrm>
           <a:prstGeom prst="rect">
@@ -11067,7 +11595,7 @@
         </p:nvSpPr>
         <p:spPr>
           <a:xfrm>
-            <a:off x="621792" y="1417320"/>
+            <a:off x="621792" y="1252728"/>
             <a:ext cx="3206496" cy="384048"/>
           </a:xfrm>
           <a:prstGeom prst="rect">
@@ -11102,8 +11630,8 @@
         </p:nvSpPr>
         <p:spPr>
           <a:xfrm>
-            <a:off x="621792" y="1965960"/>
-            <a:ext cx="3206496" cy="3703320"/>
+            <a:off x="621792" y="1801368"/>
+            <a:ext cx="3206496" cy="1874519"/>
           </a:xfrm>
           <a:prstGeom prst="rect">
             <a:avLst/>
@@ -11124,7 +11652,7 @@
                 </a:solidFill>
                 <a:latin typeface="Geist"/>
               </a:rPr>
-              <a:t>Classify one 64x64 brain CT slice as normal or stroke. A clean binary question.</a:t>
+              <a:t>Classify one 64x64 brain CT slice as normal or stroke -- a clean, well-posed binary question, exactly the kind transfer learning handles well.</a:t>
             </a:r>
           </a:p>
         </p:txBody>
@@ -11137,14 +11665,14 @@
         </p:nvSpPr>
         <p:spPr>
           <a:xfrm>
-            <a:off x="4312920" y="1325880"/>
-            <a:ext cx="3535680" cy="4434840"/>
+            <a:off x="4312920" y="1161288"/>
+            <a:ext cx="3535680" cy="2606039"/>
           </a:xfrm>
           <a:prstGeom prst="rect">
             <a:avLst/>
           </a:prstGeom>
           <a:solidFill>
-            <a:srgbClr val="FAFAFC"/>
+            <a:srgbClr val="FFFFFF"/>
           </a:solidFill>
           <a:ln>
             <a:noFill/>
@@ -11181,7 +11709,7 @@
         </p:nvSpPr>
         <p:spPr>
           <a:xfrm>
-            <a:off x="4312920" y="1325880"/>
+            <a:off x="4312920" y="1161288"/>
             <a:ext cx="3535680" cy="54864"/>
           </a:xfrm>
           <a:prstGeom prst="rect">
@@ -11225,7 +11753,7 @@
         </p:nvSpPr>
         <p:spPr>
           <a:xfrm>
-            <a:off x="4477512" y="1417320"/>
+            <a:off x="4477512" y="1252728"/>
             <a:ext cx="3206496" cy="384048"/>
           </a:xfrm>
           <a:prstGeom prst="rect">
@@ -11260,8 +11788,8 @@
         </p:nvSpPr>
         <p:spPr>
           <a:xfrm>
-            <a:off x="4477512" y="1965960"/>
-            <a:ext cx="3206496" cy="3703320"/>
+            <a:off x="4477512" y="1801368"/>
+            <a:ext cx="3206496" cy="1874519"/>
           </a:xfrm>
           <a:prstGeom prst="rect">
             <a:avLst/>
@@ -11282,7 +11810,7 @@
                 </a:solidFill>
                 <a:latin typeface="Geist"/>
               </a:rPr>
-              <a:t>The CT image, and a normal / stroke label. That is the entire dataset.</a:t>
+              <a:t>The CT image, and a normal / stroke label. That is the entire dataset -- one picture in, one word out.</a:t>
             </a:r>
           </a:p>
         </p:txBody>
@@ -11295,14 +11823,14 @@
         </p:nvSpPr>
         <p:spPr>
           <a:xfrm>
-            <a:off x="8168640" y="1325880"/>
-            <a:ext cx="3535680" cy="4434840"/>
+            <a:off x="8168640" y="1161288"/>
+            <a:ext cx="3535680" cy="2606039"/>
           </a:xfrm>
           <a:prstGeom prst="rect">
             <a:avLst/>
           </a:prstGeom>
           <a:solidFill>
-            <a:srgbClr val="FAFAFC"/>
+            <a:srgbClr val="FFFFFF"/>
           </a:solidFill>
           <a:ln>
             <a:noFill/>
@@ -11339,7 +11867,7 @@
         </p:nvSpPr>
         <p:spPr>
           <a:xfrm>
-            <a:off x="8168640" y="1325880"/>
+            <a:off x="8168640" y="1161288"/>
             <a:ext cx="3535680" cy="54864"/>
           </a:xfrm>
           <a:prstGeom prst="rect">
@@ -11383,7 +11911,7 @@
         </p:nvSpPr>
         <p:spPr>
           <a:xfrm>
-            <a:off x="8333232" y="1417320"/>
+            <a:off x="8333232" y="1252728"/>
             <a:ext cx="3206496" cy="384048"/>
           </a:xfrm>
           <a:prstGeom prst="rect">
@@ -11418,8 +11946,8 @@
         </p:nvSpPr>
         <p:spPr>
           <a:xfrm>
-            <a:off x="8333232" y="1965960"/>
-            <a:ext cx="3206496" cy="3703320"/>
+            <a:off x="8333232" y="1801368"/>
+            <a:ext cx="3206496" cy="1874519"/>
           </a:xfrm>
           <a:prstGeom prst="rect">
             <a:avLst/>
@@ -11440,7 +11968,86 @@
                 </a:solidFill>
                 <a:latin typeface="Geist"/>
               </a:rPr>
-              <a:t>Age, sex, race, scanner, site, time-since-injury -- every field a fairness audit would need.</a:t>
+              <a:t>Age, sex, race, scanner, site, time-since-injury -- every field a fairness audit would need. Not one of them was recorded.</a:t>
+            </a:r>
+          </a:p>
+        </p:txBody>
+      </p:sp>
+      <p:sp>
+        <p:nvSpPr>
+          <p:cNvPr id="19" name="Rectangle 18"/>
+          <p:cNvSpPr/>
+          <p:nvPr/>
+        </p:nvSpPr>
+        <p:spPr>
+          <a:xfrm>
+            <a:off x="457200" y="4288536"/>
+            <a:ext cx="64008" cy="1042415"/>
+          </a:xfrm>
+          <a:prstGeom prst="rect">
+            <a:avLst/>
+          </a:prstGeom>
+          <a:solidFill>
+            <a:srgbClr val="FF1493"/>
+          </a:solidFill>
+          <a:ln>
+            <a:noFill/>
+          </a:ln>
+          <a:effectLst/>
+        </p:spPr>
+        <p:style>
+          <a:lnRef idx="1">
+            <a:schemeClr val="accent1"/>
+          </a:lnRef>
+          <a:fillRef idx="3">
+            <a:schemeClr val="accent1"/>
+          </a:fillRef>
+          <a:effectRef idx="2">
+            <a:schemeClr val="accent1"/>
+          </a:effectRef>
+          <a:fontRef idx="minor">
+            <a:schemeClr val="lt1"/>
+          </a:fontRef>
+        </p:style>
+        <p:txBody>
+          <a:bodyPr rtlCol="0" anchor="ctr"/>
+          <a:lstStyle/>
+          <a:p>
+            <a:pPr algn="ctr"/>
+          </a:p>
+        </p:txBody>
+      </p:sp>
+      <p:sp>
+        <p:nvSpPr>
+          <p:cNvPr id="20" name="TextBox 19"/>
+          <p:cNvSpPr txBox="1"/>
+          <p:nvPr/>
+        </p:nvSpPr>
+        <p:spPr>
+          <a:xfrm>
+            <a:off x="731520" y="4288536"/>
+            <a:ext cx="10972800" cy="1042415"/>
+          </a:xfrm>
+          <a:prstGeom prst="rect">
+            <a:avLst/>
+          </a:prstGeom>
+          <a:noFill/>
+        </p:spPr>
+        <p:txBody>
+          <a:bodyPr wrap="square" anchor="ctr" lIns="0" rIns="0" tIns="0" bIns="0">
+            <a:spAutoFit/>
+          </a:bodyPr>
+          <a:lstStyle/>
+          <a:p>
+            <a:pPr algn="l"/>
+            <a:r>
+              <a:rPr sz="1800" b="0" i="1">
+                <a:solidFill>
+                  <a:srgbClr val="14141C"/>
+                </a:solidFill>
+                <a:latin typeface="Geist"/>
+              </a:rPr>
+              <a:t>Hold onto that empty "Missing" column -- it turns out to be the whole finding of this project.</a:t>
             </a:r>
           </a:p>
         </p:txBody>
@@ -11673,8 +12280,8 @@
         </p:nvSpPr>
         <p:spPr>
           <a:xfrm>
-            <a:off x="457200" y="1188720"/>
-            <a:ext cx="11247120" cy="1234440"/>
+            <a:off x="457200" y="1143000"/>
+            <a:ext cx="11247120" cy="1143000"/>
           </a:xfrm>
           <a:prstGeom prst="rect">
             <a:avLst/>
@@ -11708,8 +12315,8 @@
         </p:nvSpPr>
         <p:spPr>
           <a:xfrm>
-            <a:off x="457200" y="2743200"/>
-            <a:ext cx="3413760" cy="960120"/>
+            <a:off x="457200" y="2606040"/>
+            <a:ext cx="3413760" cy="1563623"/>
           </a:xfrm>
           <a:prstGeom prst="rect">
             <a:avLst/>
@@ -11752,7 +12359,7 @@
         </p:nvSpPr>
         <p:spPr>
           <a:xfrm>
-            <a:off x="457200" y="2743200"/>
+            <a:off x="457200" y="2606040"/>
             <a:ext cx="3413760" cy="91440"/>
           </a:xfrm>
           <a:prstGeom prst="rect">
@@ -11796,8 +12403,8 @@
         </p:nvSpPr>
         <p:spPr>
           <a:xfrm>
-            <a:off x="658368" y="2999232"/>
-            <a:ext cx="3011424" cy="502920"/>
+            <a:off x="658368" y="2843784"/>
+            <a:ext cx="3011424" cy="457200"/>
           </a:xfrm>
           <a:prstGeom prst="rect">
             <a:avLst/>
@@ -11805,7 +12412,7 @@
           <a:noFill/>
         </p:spPr>
         <p:txBody>
-          <a:bodyPr wrap="square" anchor="ctr" lIns="0" rIns="0" tIns="0" bIns="0">
+          <a:bodyPr wrap="square" anchor="t" lIns="0" rIns="0" tIns="0" bIns="0">
             <a:spAutoFit/>
           </a:bodyPr>
           <a:lstStyle/>
@@ -11831,7 +12438,42 @@
         </p:nvSpPr>
         <p:spPr>
           <a:xfrm>
-            <a:off x="3980688" y="2999232"/>
+            <a:off x="658368" y="3337560"/>
+            <a:ext cx="3011424" cy="740663"/>
+          </a:xfrm>
+          <a:prstGeom prst="rect">
+            <a:avLst/>
+          </a:prstGeom>
+          <a:noFill/>
+        </p:spPr>
+        <p:txBody>
+          <a:bodyPr wrap="square" anchor="t" lIns="0" rIns="0" tIns="0" bIns="0">
+            <a:spAutoFit/>
+          </a:bodyPr>
+          <a:lstStyle/>
+          <a:p>
+            <a:pPr algn="l"/>
+            <a:r>
+              <a:rPr sz="1200" b="0" i="0">
+                <a:solidFill>
+                  <a:srgbClr val="14141C"/>
+                </a:solidFill>
+                <a:latin typeface="Geist"/>
+              </a:rPr>
+              <a:t>Learned edges, shapes, and texture from ~1M everyday photos.</a:t>
+            </a:r>
+          </a:p>
+        </p:txBody>
+      </p:sp>
+      <p:sp>
+        <p:nvSpPr>
+          <p:cNvPr id="12" name="TextBox 11"/>
+          <p:cNvSpPr txBox="1"/>
+          <p:nvPr/>
+        </p:nvSpPr>
+        <p:spPr>
+          <a:xfrm>
+            <a:off x="3989832" y="3075127"/>
             <a:ext cx="320040" cy="457200"/>
           </a:xfrm>
           <a:prstGeom prst="rect">
@@ -11849,7 +12491,7 @@
             <a:r>
               <a:rPr sz="2400" b="1" i="0">
                 <a:solidFill>
-                  <a:srgbClr val="555560"/>
+                  <a:srgbClr val="40E0D0"/>
                 </a:solidFill>
                 <a:latin typeface="Geist Mono"/>
               </a:rPr>
@@ -11860,14 +12502,14 @@
       </p:sp>
       <p:sp>
         <p:nvSpPr>
-          <p:cNvPr id="12" name="Rectangle 11"/>
+          <p:cNvPr id="13" name="Rectangle 12"/>
           <p:cNvSpPr/>
           <p:nvPr/>
         </p:nvSpPr>
         <p:spPr>
           <a:xfrm>
-            <a:off x="4373880" y="2743200"/>
-            <a:ext cx="3413760" cy="960120"/>
+            <a:off x="4373880" y="2606040"/>
+            <a:ext cx="3413760" cy="1563623"/>
           </a:xfrm>
           <a:prstGeom prst="rect">
             <a:avLst/>
@@ -11904,13 +12546,13 @@
       </p:sp>
       <p:sp>
         <p:nvSpPr>
-          <p:cNvPr id="13" name="Rectangle 12"/>
+          <p:cNvPr id="14" name="Rectangle 13"/>
           <p:cNvSpPr/>
           <p:nvPr/>
         </p:nvSpPr>
         <p:spPr>
           <a:xfrm>
-            <a:off x="4373880" y="2743200"/>
+            <a:off x="4373880" y="2606040"/>
             <a:ext cx="3413760" cy="91440"/>
           </a:xfrm>
           <a:prstGeom prst="rect">
@@ -11948,14 +12590,14 @@
       </p:sp>
       <p:sp>
         <p:nvSpPr>
-          <p:cNvPr id="14" name="TextBox 13"/>
+          <p:cNvPr id="15" name="TextBox 14"/>
           <p:cNvSpPr txBox="1"/>
           <p:nvPr/>
         </p:nvSpPr>
         <p:spPr>
           <a:xfrm>
-            <a:off x="4575048" y="2999232"/>
-            <a:ext cx="3011424" cy="502920"/>
+            <a:off x="4575048" y="2843784"/>
+            <a:ext cx="3011424" cy="457200"/>
           </a:xfrm>
           <a:prstGeom prst="rect">
             <a:avLst/>
@@ -11963,7 +12605,7 @@
           <a:noFill/>
         </p:spPr>
         <p:txBody>
-          <a:bodyPr wrap="square" anchor="ctr" lIns="0" rIns="0" tIns="0" bIns="0">
+          <a:bodyPr wrap="square" anchor="t" lIns="0" rIns="0" tIns="0" bIns="0">
             <a:spAutoFit/>
           </a:bodyPr>
           <a:lstStyle/>
@@ -11983,13 +12625,48 @@
       </p:sp>
       <p:sp>
         <p:nvSpPr>
-          <p:cNvPr id="15" name="TextBox 14"/>
+          <p:cNvPr id="16" name="TextBox 15"/>
           <p:cNvSpPr txBox="1"/>
           <p:nvPr/>
         </p:nvSpPr>
         <p:spPr>
           <a:xfrm>
-            <a:off x="7897368" y="2999232"/>
+            <a:off x="4575048" y="3337560"/>
+            <a:ext cx="3011424" cy="740663"/>
+          </a:xfrm>
+          <a:prstGeom prst="rect">
+            <a:avLst/>
+          </a:prstGeom>
+          <a:noFill/>
+        </p:spPr>
+        <p:txBody>
+          <a:bodyPr wrap="square" anchor="t" lIns="0" rIns="0" tIns="0" bIns="0">
+            <a:spAutoFit/>
+          </a:bodyPr>
+          <a:lstStyle/>
+          <a:p>
+            <a:pPr algn="l"/>
+            <a:r>
+              <a:rPr sz="1200" b="0" i="0">
+                <a:solidFill>
+                  <a:srgbClr val="14141C"/>
+                </a:solidFill>
+                <a:latin typeface="Geist"/>
+              </a:rPr>
+              <a:t>Keep those features frozen -- do not spend our few scans re-learning them.</a:t>
+            </a:r>
+          </a:p>
+        </p:txBody>
+      </p:sp>
+      <p:sp>
+        <p:nvSpPr>
+          <p:cNvPr id="17" name="TextBox 16"/>
+          <p:cNvSpPr txBox="1"/>
+          <p:nvPr/>
+        </p:nvSpPr>
+        <p:spPr>
+          <a:xfrm>
+            <a:off x="7906512" y="3075127"/>
             <a:ext cx="320040" cy="457200"/>
           </a:xfrm>
           <a:prstGeom prst="rect">
@@ -12007,7 +12684,7 @@
             <a:r>
               <a:rPr sz="2400" b="1" i="0">
                 <a:solidFill>
-                  <a:srgbClr val="555560"/>
+                  <a:srgbClr val="F0C840"/>
                 </a:solidFill>
                 <a:latin typeface="Geist Mono"/>
               </a:rPr>
@@ -12018,14 +12695,14 @@
       </p:sp>
       <p:sp>
         <p:nvSpPr>
-          <p:cNvPr id="16" name="Rectangle 15"/>
+          <p:cNvPr id="18" name="Rectangle 17"/>
           <p:cNvSpPr/>
           <p:nvPr/>
         </p:nvSpPr>
         <p:spPr>
           <a:xfrm>
-            <a:off x="8290560" y="2743200"/>
-            <a:ext cx="3413760" cy="960120"/>
+            <a:off x="8290560" y="2606040"/>
+            <a:ext cx="3413760" cy="1563623"/>
           </a:xfrm>
           <a:prstGeom prst="rect">
             <a:avLst/>
@@ -12062,13 +12739,13 @@
       </p:sp>
       <p:sp>
         <p:nvSpPr>
-          <p:cNvPr id="17" name="Rectangle 16"/>
+          <p:cNvPr id="19" name="Rectangle 18"/>
           <p:cNvSpPr/>
           <p:nvPr/>
         </p:nvSpPr>
         <p:spPr>
           <a:xfrm>
-            <a:off x="8290560" y="2743200"/>
+            <a:off x="8290560" y="2606040"/>
             <a:ext cx="3413760" cy="91440"/>
           </a:xfrm>
           <a:prstGeom prst="rect">
@@ -12106,14 +12783,14 @@
       </p:sp>
       <p:sp>
         <p:nvSpPr>
-          <p:cNvPr id="18" name="TextBox 17"/>
+          <p:cNvPr id="20" name="TextBox 19"/>
           <p:cNvSpPr txBox="1"/>
           <p:nvPr/>
         </p:nvSpPr>
         <p:spPr>
           <a:xfrm>
-            <a:off x="8491728" y="2999232"/>
-            <a:ext cx="3011424" cy="502920"/>
+            <a:off x="8491728" y="2843784"/>
+            <a:ext cx="3011424" cy="457200"/>
           </a:xfrm>
           <a:prstGeom prst="rect">
             <a:avLst/>
@@ -12121,7 +12798,7 @@
           <a:noFill/>
         </p:spPr>
         <p:txBody>
-          <a:bodyPr wrap="square" anchor="ctr" lIns="0" rIns="0" tIns="0" bIns="0">
+          <a:bodyPr wrap="square" anchor="t" lIns="0" rIns="0" tIns="0" bIns="0">
             <a:spAutoFit/>
           </a:bodyPr>
           <a:lstStyle/>
@@ -12135,6 +12812,120 @@
                 <a:latin typeface="Geist Mono"/>
               </a:rPr>
               <a:t>Train a new 2-class head</a:t>
+            </a:r>
+          </a:p>
+        </p:txBody>
+      </p:sp>
+      <p:sp>
+        <p:nvSpPr>
+          <p:cNvPr id="21" name="TextBox 20"/>
+          <p:cNvSpPr txBox="1"/>
+          <p:nvPr/>
+        </p:nvSpPr>
+        <p:spPr>
+          <a:xfrm>
+            <a:off x="8491728" y="3337560"/>
+            <a:ext cx="3011424" cy="740663"/>
+          </a:xfrm>
+          <a:prstGeom prst="rect">
+            <a:avLst/>
+          </a:prstGeom>
+          <a:noFill/>
+        </p:spPr>
+        <p:txBody>
+          <a:bodyPr wrap="square" anchor="t" lIns="0" rIns="0" tIns="0" bIns="0">
+            <a:spAutoFit/>
+          </a:bodyPr>
+          <a:lstStyle/>
+          <a:p>
+            <a:pPr algn="l"/>
+            <a:r>
+              <a:rPr sz="1200" b="0" i="0">
+                <a:solidFill>
+                  <a:srgbClr val="14141C"/>
+                </a:solidFill>
+                <a:latin typeface="Geist"/>
+              </a:rPr>
+              <a:t>Train only this small layer to map features to normal vs. stroke.</a:t>
+            </a:r>
+          </a:p>
+        </p:txBody>
+      </p:sp>
+      <p:sp>
+        <p:nvSpPr>
+          <p:cNvPr id="22" name="Rectangle 21"/>
+          <p:cNvSpPr/>
+          <p:nvPr/>
+        </p:nvSpPr>
+        <p:spPr>
+          <a:xfrm>
+            <a:off x="457200" y="4586630"/>
+            <a:ext cx="64008" cy="886053"/>
+          </a:xfrm>
+          <a:prstGeom prst="rect">
+            <a:avLst/>
+          </a:prstGeom>
+          <a:solidFill>
+            <a:srgbClr val="40E0D0"/>
+          </a:solidFill>
+          <a:ln>
+            <a:noFill/>
+          </a:ln>
+          <a:effectLst/>
+        </p:spPr>
+        <p:style>
+          <a:lnRef idx="1">
+            <a:schemeClr val="accent1"/>
+          </a:lnRef>
+          <a:fillRef idx="3">
+            <a:schemeClr val="accent1"/>
+          </a:fillRef>
+          <a:effectRef idx="2">
+            <a:schemeClr val="accent1"/>
+          </a:effectRef>
+          <a:fontRef idx="minor">
+            <a:schemeClr val="lt1"/>
+          </a:fontRef>
+        </p:style>
+        <p:txBody>
+          <a:bodyPr rtlCol="0" anchor="ctr"/>
+          <a:lstStyle/>
+          <a:p>
+            <a:pPr algn="ctr"/>
+          </a:p>
+        </p:txBody>
+      </p:sp>
+      <p:sp>
+        <p:nvSpPr>
+          <p:cNvPr id="23" name="TextBox 22"/>
+          <p:cNvSpPr txBox="1"/>
+          <p:nvPr/>
+        </p:nvSpPr>
+        <p:spPr>
+          <a:xfrm>
+            <a:off x="731520" y="4586630"/>
+            <a:ext cx="10972800" cy="886053"/>
+          </a:xfrm>
+          <a:prstGeom prst="rect">
+            <a:avLst/>
+          </a:prstGeom>
+          <a:noFill/>
+        </p:spPr>
+        <p:txBody>
+          <a:bodyPr wrap="square" anchor="ctr" lIns="0" rIns="0" tIns="0" bIns="0">
+            <a:spAutoFit/>
+          </a:bodyPr>
+          <a:lstStyle/>
+          <a:p>
+            <a:pPr algn="l"/>
+            <a:r>
+              <a:rPr sz="1700" b="0" i="0">
+                <a:solidFill>
+                  <a:srgbClr val="14141C"/>
+                </a:solidFill>
+                <a:latin typeface="Geist"/>
+              </a:rPr>
+              <a:t>The habit: when data is small, start from something already pretrained -- never train a big network from scratch.</a:t>
             </a:r>
           </a:p>
         </p:txBody>

</xml_diff>